<commit_message>
Fix stretched logos + add client deck template
Two fixes to the brand-guide PPTX (cover + logo slides used pptxgenjs
'sizing: contain' which doesn't preserve aspect; replaced with
per-image dimensions matching each file's natural aspect ratio).

Add PikeSquare-Deck-Template.pptx — 10-slide starter for client
presentations (title, agenda, section divider, content, two-column,
three-pillar, big-stat, quote, process, closing) with the brand baked
into the master. One PPTX serves both PowerPoint and Google Slides
(Drive imports cleanly).

Co-Authored-By: Claude Opus 4.7 (1M context) <noreply@anthropic.com>
</commit_message>
<xml_diff>
--- a/public/brand/PikeSquare-Brand-Guide.pptx
+++ b/public/brand/PikeSquare-Brand-Guide.pptx
@@ -1596,7 +1596,7 @@
         <p:spPr>
           <a:xfrm>
             <a:off x="548640" y="502920"/>
-            <a:ext cx="2377440" cy="777240"/>
+            <a:ext cx="1743761" cy="777240"/>
           </a:xfrm>
           <a:prstGeom prst="rect">
             <a:avLst/>
@@ -1622,13 +1622,14 @@
         </p:nvPicPr>
         <p:blipFill>
           <a:blip r:embed="rId1"/>
-          <a:srcRect l="0" r="0" t="0" b="0"/>
-          <a:stretch/>
+          <a:stretch>
+            <a:fillRect/>
+          </a:stretch>
         </p:blipFill>
         <p:spPr>
           <a:xfrm>
-            <a:off x="685800" y="594360"/>
-            <a:ext cx="2103120" cy="594360"/>
+            <a:off x="731520" y="640080"/>
+            <a:ext cx="1378001" cy="502920"/>
           </a:xfrm>
           <a:prstGeom prst="rect">
             <a:avLst/>
@@ -2567,13 +2568,14 @@
         </p:nvPicPr>
         <p:blipFill>
           <a:blip r:embed="rId1"/>
-          <a:srcRect l="0" r="0" t="0" b="0"/>
-          <a:stretch/>
+          <a:stretch>
+            <a:fillRect/>
+          </a:stretch>
         </p:blipFill>
         <p:spPr>
           <a:xfrm>
-            <a:off x="914400" y="2560320"/>
-            <a:ext cx="1828800" cy="1097280"/>
+            <a:off x="914400" y="2775237"/>
+            <a:ext cx="1828800" cy="667445"/>
           </a:xfrm>
           <a:prstGeom prst="rect">
             <a:avLst/>
@@ -2693,13 +2695,14 @@
         </p:nvPicPr>
         <p:blipFill>
           <a:blip r:embed="rId2"/>
-          <a:srcRect l="0" r="0" t="0" b="0"/>
-          <a:stretch/>
+          <a:stretch>
+            <a:fillRect/>
+          </a:stretch>
         </p:blipFill>
         <p:spPr>
           <a:xfrm>
-            <a:off x="3657600" y="2560320"/>
-            <a:ext cx="1828800" cy="1097280"/>
+            <a:off x="3657600" y="2724758"/>
+            <a:ext cx="1828800" cy="768403"/>
           </a:xfrm>
           <a:prstGeom prst="rect">
             <a:avLst/>
@@ -2819,13 +2822,14 @@
         </p:nvPicPr>
         <p:blipFill>
           <a:blip r:embed="rId3"/>
-          <a:srcRect l="0" r="0" t="0" b="0"/>
-          <a:stretch/>
+          <a:stretch>
+            <a:fillRect/>
+          </a:stretch>
         </p:blipFill>
         <p:spPr>
           <a:xfrm>
-            <a:off x="6400800" y="2560320"/>
-            <a:ext cx="1828800" cy="1097280"/>
+            <a:off x="6766560" y="2560320"/>
+            <a:ext cx="1097280" cy="1097280"/>
           </a:xfrm>
           <a:prstGeom prst="rect">
             <a:avLst/>

</xml_diff>